<commit_message>
innovatex-t2-aqi: evaluator v2.1 stress tests + fair baseline; spike holds at -17% (holdout); deck/pitch/ADR updated
</commit_message>
<xml_diff>
--- a/innovatex-t2-aqi/deliverables/deck/DustLedger_zonal.pptx
+++ b/innovatex-t2-aqi/deliverables/deck/DustLedger_zonal.pptx
@@ -1213,7 +1213,7 @@
           <a:lstStyle/>
           <a:p>
             <a:r>
-              <a:t>In a replay with real Delhi background and real wind, but a simulated site and sensors, a fixed upwind/downwind pair is badly wrong because the wind keeps changing direction. A wind-resolved ring halves the error. Adding self-calibration from the site's quiet hours cuts it further — but that part is a hypothesis: an independent review found our simulator favours it, so we're stress-testing it before claiming it.</a:t>
+              <a:t>In a replay with real Delhi background and real wind, but a simulated site and sensors, a fixed upwind/downwind pair is badly wrong because the wind keeps changing direction. A wind-resolved ring cuts the error by about a quarter. Weekly reference visits barely help, because sensors foul and drift between visits. Re-calibrating the nodes against each other in the site's quiet hours cuts the error by another sixth, and that held up when an independent reviewer's harder stress tests were applied, including a site shape the method never saw. It's still a simulation, so we'll prove it on real hardware in November.</a:t>
             </a:r>
           </a:p>
         </p:txBody>
@@ -6892,7 +6892,7 @@
               </a:defRPr>
             </a:pPr>
             <a:r>
-              <a:t>SIMULATED site, plume and sensors on REAL background + wind</a:t>
+              <a:t>SIMULATED site, plume, sensors and faults on REAL background + wind</a:t>
             </a:r>
           </a:p>
           <a:p>
@@ -6907,7 +6907,7 @@
               </a:defRPr>
             </a:pPr>
             <a:r>
-              <a:t>Self-calibration gain = hypothesis; stress tests (evaluator v2) next</a:t>
+              <a:t>Stress tests from an independent review: fouling, dust-vs-ambient gain, dirty nights, neighbours, vane bias</a:t>
             </a:r>
           </a:p>
         </p:txBody>

</xml_diff>